<commit_message>
Slide 8: add weekly media evolution columns
Co-Authored-By: Claude Opus 5.5 <noreply@anthropic.com>
Claude-Session: https://claude.ai/code/session_01Nb2zwbsMrV1Nu6HHrqbJ9M
</commit_message>
<xml_diff>
--- a/20261016_Rapport_Boulanger_Hebdo_08.10-15.10.pptx
+++ b/20261016_Rapport_Boulanger_Hebdo_08.10-15.10.pptx
@@ -22085,7 +22085,7 @@
                 </a:solidFill>
                 <a:latin typeface="Inter"/>
               </a:rPr>
-              <a:t>Part des impressions de la campagne par site éditeur</a:t>
+              <a:t>Part des impressions de la campagne par site éditeur · évolution vs semaine précédente</a:t>
             </a:r>
             <a:endParaRPr lang="en-US" sz="850" b="0" i="0" dirty="0">
               <a:solidFill>
@@ -22263,7 +22263,7 @@
                 </a:solidFill>
                 <a:latin typeface="Inter"/>
               </a:rPr>
-              <a:t>PART</a:t>
+              <a:t>08/10 → 15/10</a:t>
             </a:r>
           </a:p>
         </p:txBody>
@@ -23863,6 +23863,482 @@
                 <a:latin typeface="Inter"/>
               </a:rPr>
               <a:t>03 PISTES DE RECO</a:t>
+            </a:r>
+          </a:p>
+        </p:txBody>
+      </p:sp>
+      <p:sp>
+        <p:nvSpPr>
+          <p:cNvPr id="113" name="TextBox 11"/>
+          <p:cNvSpPr txBox="1"/>
+          <p:nvPr/>
+        </p:nvSpPr>
+        <p:spPr>
+          <a:xfrm>
+            <a:off x="9450000" y="1901952"/>
+            <a:ext cx="914400" cy="274320"/>
+          </a:xfrm>
+          <a:prstGeom prst="rect">
+            <a:avLst/>
+          </a:prstGeom>
+          <a:noFill/>
+        </p:spPr>
+        <p:txBody>
+          <a:bodyPr wrap="square" lIns="0" tIns="0" rIns="0" bIns="0">
+            <a:spAutoFit/>
+          </a:bodyPr>
+          <a:lstStyle/>
+          <a:p>
+            <a:r>
+              <a:rPr sz="700" b="1" i="0" spc="150">
+                <a:solidFill>
+                  <a:srgbClr val="98A2B3"/>
+                </a:solidFill>
+                <a:latin typeface="Inter"/>
+              </a:rPr>
+              <a:t>01/10 → 08/10</a:t>
+            </a:r>
+          </a:p>
+        </p:txBody>
+      </p:sp>
+      <p:sp>
+        <p:nvSpPr>
+          <p:cNvPr id="113" name="TextBox 11"/>
+          <p:cNvSpPr txBox="1"/>
+          <p:nvPr/>
+        </p:nvSpPr>
+        <p:spPr>
+          <a:xfrm>
+            <a:off x="10650000" y="1901952"/>
+            <a:ext cx="914400" cy="274320"/>
+          </a:xfrm>
+          <a:prstGeom prst="rect">
+            <a:avLst/>
+          </a:prstGeom>
+          <a:noFill/>
+        </p:spPr>
+        <p:txBody>
+          <a:bodyPr wrap="square" lIns="0" tIns="0" rIns="0" bIns="0">
+            <a:spAutoFit/>
+          </a:bodyPr>
+          <a:lstStyle/>
+          <a:p>
+            <a:r>
+              <a:rPr sz="700" b="1" i="0" spc="150">
+                <a:solidFill>
+                  <a:srgbClr val="98A2B3"/>
+                </a:solidFill>
+                <a:latin typeface="Inter"/>
+              </a:rPr>
+              <a:t>ÉVOLUTION</a:t>
+            </a:r>
+          </a:p>
+        </p:txBody>
+      </p:sp>
+      <p:sp>
+        <p:nvSpPr>
+          <p:cNvPr id="120" name="TextBox 19"/>
+          <p:cNvSpPr txBox="1"/>
+          <p:nvPr/>
+        </p:nvSpPr>
+        <p:spPr>
+          <a:xfrm>
+            <a:off x="9450000" y="2314560"/>
+            <a:ext cx="914400" cy="201168"/>
+          </a:xfrm>
+          <a:prstGeom prst="rect">
+            <a:avLst/>
+          </a:prstGeom>
+          <a:noFill/>
+        </p:spPr>
+        <p:txBody>
+          <a:bodyPr wrap="square" lIns="0" tIns="0" rIns="0" bIns="0">
+            <a:spAutoFit/>
+          </a:bodyPr>
+          <a:lstStyle/>
+          <a:p>
+            <a:r>
+              <a:rPr sz="900" b="1" i="0">
+                <a:solidFill>
+                  <a:srgbClr val="0A0A0A"/>
+                </a:solidFill>
+                <a:latin typeface="Inter"/>
+              </a:rPr>
+              <a:t>31,6 %</a:t>
+            </a:r>
+          </a:p>
+        </p:txBody>
+      </p:sp>
+      <p:sp>
+        <p:nvSpPr>
+          <p:cNvPr id="120" name="TextBox 19"/>
+          <p:cNvSpPr txBox="1"/>
+          <p:nvPr/>
+        </p:nvSpPr>
+        <p:spPr>
+          <a:xfrm>
+            <a:off x="10650000" y="2314560"/>
+            <a:ext cx="914400" cy="201168"/>
+          </a:xfrm>
+          <a:prstGeom prst="rect">
+            <a:avLst/>
+          </a:prstGeom>
+          <a:noFill/>
+        </p:spPr>
+        <p:txBody>
+          <a:bodyPr wrap="square" lIns="0" tIns="0" rIns="0" bIns="0">
+            <a:spAutoFit/>
+          </a:bodyPr>
+          <a:lstStyle/>
+          <a:p>
+            <a:r>
+              <a:rPr sz="900" b="1" i="0">
+                <a:solidFill>
+                  <a:srgbClr val="B42318"/>
+                </a:solidFill>
+                <a:latin typeface="Inter"/>
+              </a:rPr>
+              <a:t>▼ −0,8 pt</a:t>
+            </a:r>
+          </a:p>
+        </p:txBody>
+      </p:sp>
+      <p:sp>
+        <p:nvSpPr>
+          <p:cNvPr id="128" name="TextBox 19"/>
+          <p:cNvSpPr txBox="1"/>
+          <p:nvPr/>
+        </p:nvSpPr>
+        <p:spPr>
+          <a:xfrm>
+            <a:off x="9450000" y="2794560"/>
+            <a:ext cx="914400" cy="201168"/>
+          </a:xfrm>
+          <a:prstGeom prst="rect">
+            <a:avLst/>
+          </a:prstGeom>
+          <a:noFill/>
+        </p:spPr>
+        <p:txBody>
+          <a:bodyPr wrap="square" lIns="0" tIns="0" rIns="0" bIns="0">
+            <a:spAutoFit/>
+          </a:bodyPr>
+          <a:lstStyle/>
+          <a:p>
+            <a:r>
+              <a:rPr sz="900" b="1" i="0">
+                <a:solidFill>
+                  <a:srgbClr val="0A0A0A"/>
+                </a:solidFill>
+                <a:latin typeface="Inter"/>
+              </a:rPr>
+              <a:t>27,1 %</a:t>
+            </a:r>
+          </a:p>
+        </p:txBody>
+      </p:sp>
+      <p:sp>
+        <p:nvSpPr>
+          <p:cNvPr id="128" name="TextBox 19"/>
+          <p:cNvSpPr txBox="1"/>
+          <p:nvPr/>
+        </p:nvSpPr>
+        <p:spPr>
+          <a:xfrm>
+            <a:off x="10650000" y="2794560"/>
+            <a:ext cx="914400" cy="201168"/>
+          </a:xfrm>
+          <a:prstGeom prst="rect">
+            <a:avLst/>
+          </a:prstGeom>
+          <a:noFill/>
+        </p:spPr>
+        <p:txBody>
+          <a:bodyPr wrap="square" lIns="0" tIns="0" rIns="0" bIns="0">
+            <a:spAutoFit/>
+          </a:bodyPr>
+          <a:lstStyle/>
+          <a:p>
+            <a:r>
+              <a:rPr sz="900" b="1" i="0">
+                <a:solidFill>
+                  <a:srgbClr val="196B24"/>
+                </a:solidFill>
+                <a:latin typeface="Inter"/>
+              </a:rPr>
+              <a:t>▲ +0,5 pt</a:t>
+            </a:r>
+          </a:p>
+        </p:txBody>
+      </p:sp>
+      <p:sp>
+        <p:nvSpPr>
+          <p:cNvPr id="136" name="TextBox 19"/>
+          <p:cNvSpPr txBox="1"/>
+          <p:nvPr/>
+        </p:nvSpPr>
+        <p:spPr>
+          <a:xfrm>
+            <a:off x="9450000" y="3274560"/>
+            <a:ext cx="914400" cy="201168"/>
+          </a:xfrm>
+          <a:prstGeom prst="rect">
+            <a:avLst/>
+          </a:prstGeom>
+          <a:noFill/>
+        </p:spPr>
+        <p:txBody>
+          <a:bodyPr wrap="square" lIns="0" tIns="0" rIns="0" bIns="0">
+            <a:spAutoFit/>
+          </a:bodyPr>
+          <a:lstStyle/>
+          <a:p>
+            <a:r>
+              <a:rPr sz="900" b="1" i="0">
+                <a:solidFill>
+                  <a:srgbClr val="0A0A0A"/>
+                </a:solidFill>
+                <a:latin typeface="Inter"/>
+              </a:rPr>
+              <a:t>16,4 %</a:t>
+            </a:r>
+          </a:p>
+        </p:txBody>
+      </p:sp>
+      <p:sp>
+        <p:nvSpPr>
+          <p:cNvPr id="136" name="TextBox 19"/>
+          <p:cNvSpPr txBox="1"/>
+          <p:nvPr/>
+        </p:nvSpPr>
+        <p:spPr>
+          <a:xfrm>
+            <a:off x="10650000" y="3274560"/>
+            <a:ext cx="914400" cy="201168"/>
+          </a:xfrm>
+          <a:prstGeom prst="rect">
+            <a:avLst/>
+          </a:prstGeom>
+          <a:noFill/>
+        </p:spPr>
+        <p:txBody>
+          <a:bodyPr wrap="square" lIns="0" tIns="0" rIns="0" bIns="0">
+            <a:spAutoFit/>
+          </a:bodyPr>
+          <a:lstStyle/>
+          <a:p>
+            <a:r>
+              <a:rPr sz="900" b="1" i="0">
+                <a:solidFill>
+                  <a:srgbClr val="196B24"/>
+                </a:solidFill>
+                <a:latin typeface="Inter"/>
+              </a:rPr>
+              <a:t>▲ +0,5 pt</a:t>
+            </a:r>
+          </a:p>
+        </p:txBody>
+      </p:sp>
+      <p:sp>
+        <p:nvSpPr>
+          <p:cNvPr id="144" name="TextBox 19"/>
+          <p:cNvSpPr txBox="1"/>
+          <p:nvPr/>
+        </p:nvSpPr>
+        <p:spPr>
+          <a:xfrm>
+            <a:off x="9450000" y="3754560"/>
+            <a:ext cx="914400" cy="201168"/>
+          </a:xfrm>
+          <a:prstGeom prst="rect">
+            <a:avLst/>
+          </a:prstGeom>
+          <a:noFill/>
+        </p:spPr>
+        <p:txBody>
+          <a:bodyPr wrap="square" lIns="0" tIns="0" rIns="0" bIns="0">
+            <a:spAutoFit/>
+          </a:bodyPr>
+          <a:lstStyle/>
+          <a:p>
+            <a:r>
+              <a:rPr sz="900" b="1" i="0">
+                <a:solidFill>
+                  <a:srgbClr val="0A0A0A"/>
+                </a:solidFill>
+                <a:latin typeface="Inter"/>
+              </a:rPr>
+              <a:t>6,4 %</a:t>
+            </a:r>
+          </a:p>
+        </p:txBody>
+      </p:sp>
+      <p:sp>
+        <p:nvSpPr>
+          <p:cNvPr id="144" name="TextBox 19"/>
+          <p:cNvSpPr txBox="1"/>
+          <p:nvPr/>
+        </p:nvSpPr>
+        <p:spPr>
+          <a:xfrm>
+            <a:off x="10650000" y="3754560"/>
+            <a:ext cx="914400" cy="201168"/>
+          </a:xfrm>
+          <a:prstGeom prst="rect">
+            <a:avLst/>
+          </a:prstGeom>
+          <a:noFill/>
+        </p:spPr>
+        <p:txBody>
+          <a:bodyPr wrap="square" lIns="0" tIns="0" rIns="0" bIns="0">
+            <a:spAutoFit/>
+          </a:bodyPr>
+          <a:lstStyle/>
+          <a:p>
+            <a:r>
+              <a:rPr sz="900" b="1" i="0">
+                <a:solidFill>
+                  <a:srgbClr val="B42318"/>
+                </a:solidFill>
+                <a:latin typeface="Inter"/>
+              </a:rPr>
+              <a:t>▼ −0,2 pt</a:t>
+            </a:r>
+          </a:p>
+        </p:txBody>
+      </p:sp>
+      <p:sp>
+        <p:nvSpPr>
+          <p:cNvPr id="152" name="TextBox 19"/>
+          <p:cNvSpPr txBox="1"/>
+          <p:nvPr/>
+        </p:nvSpPr>
+        <p:spPr>
+          <a:xfrm>
+            <a:off x="9450000" y="4234560"/>
+            <a:ext cx="914400" cy="201168"/>
+          </a:xfrm>
+          <a:prstGeom prst="rect">
+            <a:avLst/>
+          </a:prstGeom>
+          <a:noFill/>
+        </p:spPr>
+        <p:txBody>
+          <a:bodyPr wrap="square" lIns="0" tIns="0" rIns="0" bIns="0">
+            <a:spAutoFit/>
+          </a:bodyPr>
+          <a:lstStyle/>
+          <a:p>
+            <a:r>
+              <a:rPr sz="900" b="1" i="0">
+                <a:solidFill>
+                  <a:srgbClr val="0A0A0A"/>
+                </a:solidFill>
+                <a:latin typeface="Inter"/>
+              </a:rPr>
+              <a:t>6,3 %</a:t>
+            </a:r>
+          </a:p>
+        </p:txBody>
+      </p:sp>
+      <p:sp>
+        <p:nvSpPr>
+          <p:cNvPr id="152" name="TextBox 19"/>
+          <p:cNvSpPr txBox="1"/>
+          <p:nvPr/>
+        </p:nvSpPr>
+        <p:spPr>
+          <a:xfrm>
+            <a:off x="10650000" y="4234560"/>
+            <a:ext cx="914400" cy="201168"/>
+          </a:xfrm>
+          <a:prstGeom prst="rect">
+            <a:avLst/>
+          </a:prstGeom>
+          <a:noFill/>
+        </p:spPr>
+        <p:txBody>
+          <a:bodyPr wrap="square" lIns="0" tIns="0" rIns="0" bIns="0">
+            <a:spAutoFit/>
+          </a:bodyPr>
+          <a:lstStyle/>
+          <a:p>
+            <a:r>
+              <a:rPr sz="900" b="1" i="0">
+                <a:solidFill>
+                  <a:srgbClr val="B42318"/>
+                </a:solidFill>
+                <a:latin typeface="Inter"/>
+              </a:rPr>
+              <a:t>▼ −0,3 pt</a:t>
+            </a:r>
+          </a:p>
+        </p:txBody>
+      </p:sp>
+      <p:sp>
+        <p:nvSpPr>
+          <p:cNvPr id="160" name="TextBox 19"/>
+          <p:cNvSpPr txBox="1"/>
+          <p:nvPr/>
+        </p:nvSpPr>
+        <p:spPr>
+          <a:xfrm>
+            <a:off x="9450000" y="4714560"/>
+            <a:ext cx="914400" cy="201168"/>
+          </a:xfrm>
+          <a:prstGeom prst="rect">
+            <a:avLst/>
+          </a:prstGeom>
+          <a:noFill/>
+        </p:spPr>
+        <p:txBody>
+          <a:bodyPr wrap="square" lIns="0" tIns="0" rIns="0" bIns="0">
+            <a:spAutoFit/>
+          </a:bodyPr>
+          <a:lstStyle/>
+          <a:p>
+            <a:r>
+              <a:rPr sz="900" b="1" i="0">
+                <a:solidFill>
+                  <a:srgbClr val="0A0A0A"/>
+                </a:solidFill>
+                <a:latin typeface="Inter"/>
+              </a:rPr>
+              <a:t>12,2 %</a:t>
+            </a:r>
+          </a:p>
+        </p:txBody>
+      </p:sp>
+      <p:sp>
+        <p:nvSpPr>
+          <p:cNvPr id="160" name="TextBox 19"/>
+          <p:cNvSpPr txBox="1"/>
+          <p:nvPr/>
+        </p:nvSpPr>
+        <p:spPr>
+          <a:xfrm>
+            <a:off x="10650000" y="4714560"/>
+            <a:ext cx="914400" cy="201168"/>
+          </a:xfrm>
+          <a:prstGeom prst="rect">
+            <a:avLst/>
+          </a:prstGeom>
+          <a:noFill/>
+        </p:spPr>
+        <p:txBody>
+          <a:bodyPr wrap="square" lIns="0" tIns="0" rIns="0" bIns="0">
+            <a:spAutoFit/>
+          </a:bodyPr>
+          <a:lstStyle/>
+          <a:p>
+            <a:r>
+              <a:rPr sz="900" b="1" i="0">
+                <a:solidFill>
+                  <a:srgbClr val="196B24"/>
+                </a:solidFill>
+                <a:latin typeface="Inter"/>
+              </a:rPr>
+              <a:t>▲ +0,3 pt</a:t>
             </a:r>
           </a:p>
         </p:txBody>

</xml_diff>